<commit_message>
Slide 2: translate Top 10 for bankers, restate the two-location split
- Replace the bare 'TOP 10' credential with 'BIG-FIRM TRAINED' and copy
  that says what it buys a credit officer: Directors and Managers from
  top 10 national firms, a tier above regional practices, and the review
  discipline that produces schedules that tie
- Expand multi-industry and private equity from fragments into claims
  that connect to underwriting
- Location labels now carry the service level: 'SCOTTSDALE · CONTROLLER
  & CFO' and 'EUROPE · STAFF ACCOUNTING', so the division of labor reads
  at a glance
- State the European team as distributed across several cities rather
  than implying a single branch office
- Move the firm-wide 10+ year minimum into the closing line, where it
  covers both locations

Co-Authored-By: Claude Opus 5 <noreply@anthropic.com>
Claude-Session: https://claude.ai/code/session_01Ce7EAnEDcbrrVKC8mifefs
</commit_message>
<xml_diff>
--- a/Onyx_TrustBank_Presentation_8.pptx
+++ b/Onyx_TrustBank_Presentation_8.pptx
@@ -1980,7 +1980,7 @@
         <p:spPr>
           <a:xfrm>
             <a:off x="548640" y="1691640"/>
-            <a:ext cx="11064240" cy="2350008"/>
+            <a:ext cx="11064240" cy="2487168"/>
           </a:xfrm>
           <a:prstGeom prst="roundRect">
             <a:avLst>
@@ -2400,7 +2400,7 @@
                 <a:ea typeface="Calibri" pitchFamily="34" charset="-122"/>
                 <a:cs typeface="Calibri" pitchFamily="34" charset="-120"/>
               </a:rPr>
-              <a:t>UNITED STATES · SCOTTSDALE</a:t>
+              <a:t>SCOTTSDALE · CONTROLLER &amp; CFO</a:t>
             </a:r>
             <a:endParaRPr lang="en-US" sz="1100" dirty="0"/>
           </a:p>
@@ -2415,7 +2415,7 @@
         <p:spPr>
           <a:xfrm>
             <a:off x="841248" y="3337560"/>
-            <a:ext cx="5010912" cy="411480"/>
+            <a:ext cx="5010912" cy="548640"/>
           </a:xfrm>
           <a:prstGeom prst="rect">
             <a:avLst/>
@@ -2442,7 +2442,7 @@
                 <a:ea typeface="Calibri" pitchFamily="34" charset="-122"/>
                 <a:cs typeface="Calibri" pitchFamily="34" charset="-120"/>
               </a:rPr>
-              <a:t>Leadership, controller and CFO work, and the client relationship.</a:t>
+              <a:t>Month-end close, reporting, budgets, forecasts and financing support.</a:t>
             </a:r>
             <a:endParaRPr lang="en-US" sz="1000" dirty="0"/>
           </a:p>
@@ -2462,7 +2462,7 @@
                 <a:ea typeface="Calibri" pitchFamily="34" charset="-122"/>
                 <a:cs typeface="Calibri" pitchFamily="34" charset="-120"/>
               </a:rPr>
-              <a:t>Every accountant on the team: 10+ years minimum.</a:t>
+              <a:t>Leadership and the client relationship sit here.</a:t>
             </a:r>
             <a:endParaRPr lang="en-US" sz="1000" dirty="0"/>
           </a:p>
@@ -2501,7 +2501,7 @@
                 <a:ea typeface="Calibri" pitchFamily="34" charset="-122"/>
                 <a:cs typeface="Calibri" pitchFamily="34" charset="-120"/>
               </a:rPr>
-              <a:t>EUROPE</a:t>
+              <a:t>EUROPE · STAFF ACCOUNTING</a:t>
             </a:r>
             <a:endParaRPr lang="en-US" sz="1100" dirty="0"/>
           </a:p>
@@ -2516,7 +2516,7 @@
         <p:spPr>
           <a:xfrm>
             <a:off x="6309360" y="3337560"/>
-            <a:ext cx="5010912" cy="411480"/>
+            <a:ext cx="5010912" cy="548640"/>
           </a:xfrm>
           <a:prstGeom prst="rect">
             <a:avLst/>
@@ -2543,7 +2543,7 @@
                 <a:ea typeface="Calibri" pitchFamily="34" charset="-122"/>
                 <a:cs typeface="Calibri" pitchFamily="34" charset="-120"/>
               </a:rPr>
-              <a:t>Staff accounting: transaction detail, reconciliations and close support.</a:t>
+              <a:t>Transaction detail, reconciliations and the close support behind every engagement.</a:t>
             </a:r>
             <a:endParaRPr lang="en-US" sz="1000" dirty="0"/>
           </a:p>
@@ -2563,7 +2563,7 @@
                 <a:ea typeface="Calibri" pitchFamily="34" charset="-122"/>
                 <a:cs typeface="Calibri" pitchFamily="34" charset="-120"/>
               </a:rPr>
-              <a:t>Plus firm-wide support and global IT.</a:t>
+              <a:t>A distributed team across several European cities, on our systems and our review process.</a:t>
             </a:r>
             <a:endParaRPr lang="en-US" sz="1000" dirty="0"/>
           </a:p>
@@ -2577,7 +2577,7 @@
         </p:nvCxnSpPr>
         <p:spPr>
           <a:xfrm>
-            <a:off x="548640" y="4297680"/>
+            <a:off x="548640" y="4434840"/>
             <a:ext cx="11064240" cy="0"/>
           </a:xfrm>
           <a:prstGeom prst="line">
@@ -2612,7 +2612,7 @@
         </p:nvSpPr>
         <p:spPr>
           <a:xfrm>
-            <a:off x="548640" y="4617720"/>
+            <a:off x="548640" y="4663440"/>
             <a:ext cx="2606040" cy="320040"/>
           </a:xfrm>
           <a:prstGeom prst="rect">
@@ -2629,7 +2629,7 @@
               <a:buNone/>
             </a:pPr>
             <a:r>
-              <a:rPr lang="en-US" sz="1700" b="1" kern="0" dirty="0">
+              <a:rPr lang="en-US" sz="1500" b="1" kern="0" dirty="0">
                 <a:solidFill>
                   <a:srgbClr val="B08D57"/>
                 </a:solidFill>
@@ -2637,9 +2637,9 @@
                 <a:ea typeface="Cambria" pitchFamily="34" charset="-122"/>
                 <a:cs typeface="Cambria" pitchFamily="34" charset="-120"/>
               </a:rPr>
-              <a:t>TOP 10</a:t>
-            </a:r>
-            <a:endParaRPr lang="en-US" sz="1700" dirty="0"/>
+              <a:t>BIG-FIRM TRAINED</a:t>
+            </a:r>
+            <a:endParaRPr lang="en-US" sz="1500" dirty="0"/>
           </a:p>
         </p:txBody>
       </p:sp>
@@ -2652,7 +2652,7 @@
         <p:spPr>
           <a:xfrm>
             <a:off x="548640" y="4983480"/>
-            <a:ext cx="2606040" cy="548640"/>
+            <a:ext cx="2606040" cy="731520"/>
           </a:xfrm>
           <a:prstGeom prst="rect">
             <a:avLst/>
@@ -2666,7 +2666,7 @@
           <a:p>
             <a:pPr marL="0" indent="0" algn="l">
               <a:lnSpc>
-                <a:spcPct val="112000"/>
+                <a:spcPct val="115000"/>
               </a:lnSpc>
               <a:buNone/>
             </a:pPr>
@@ -2679,7 +2679,7 @@
                 <a:ea typeface="Calibri" pitchFamily="34" charset="-122"/>
                 <a:cs typeface="Calibri" pitchFamily="34" charset="-120"/>
               </a:rPr>
-              <a:t>former Directors &amp; Managers of Top 10 accounting firms</a:t>
+              <a:t>Directors and Managers from top 10 national accounting firms — the tier above regional practices. You get that review discipline: schedules that tie and support assembled up front.</a:t>
             </a:r>
             <a:endParaRPr lang="en-US" sz="900" dirty="0"/>
           </a:p>
@@ -2693,7 +2693,7 @@
         </p:nvSpPr>
         <p:spPr>
           <a:xfrm>
-            <a:off x="3383280" y="4617720"/>
+            <a:off x="3383280" y="4663440"/>
             <a:ext cx="2606040" cy="320040"/>
           </a:xfrm>
           <a:prstGeom prst="rect">
@@ -2710,7 +2710,7 @@
               <a:buNone/>
             </a:pPr>
             <a:r>
-              <a:rPr lang="en-US" sz="1700" b="1" kern="0" dirty="0">
+              <a:rPr lang="en-US" sz="1500" b="1" kern="0" dirty="0">
                 <a:solidFill>
                   <a:srgbClr val="B08D57"/>
                 </a:solidFill>
@@ -2720,7 +2720,7 @@
               </a:rPr>
               <a:t>MULTI-INDUSTRY</a:t>
             </a:r>
-            <a:endParaRPr lang="en-US" sz="1700" dirty="0"/>
+            <a:endParaRPr lang="en-US" sz="1500" dirty="0"/>
           </a:p>
         </p:txBody>
       </p:sp>
@@ -2733,7 +2733,7 @@
         <p:spPr>
           <a:xfrm>
             <a:off x="3383280" y="4983480"/>
-            <a:ext cx="2606040" cy="548640"/>
+            <a:ext cx="2606040" cy="731520"/>
           </a:xfrm>
           <a:prstGeom prst="rect">
             <a:avLst/>
@@ -2747,7 +2747,7 @@
           <a:p>
             <a:pPr marL="0" indent="0" algn="l">
               <a:lnSpc>
-                <a:spcPct val="112000"/>
+                <a:spcPct val="115000"/>
               </a:lnSpc>
               <a:buNone/>
             </a:pPr>
@@ -2760,7 +2760,7 @@
                 <a:ea typeface="Calibri" pitchFamily="34" charset="-122"/>
                 <a:cs typeface="Calibri" pitchFamily="34" charset="-120"/>
               </a:rPr>
-              <a:t>construction · real estate · property management · professional services · distribution</a:t>
+              <a:t>Construction · real estate · property management · professional services · distribution. We already know the schedules your credit team asks for in each one.</a:t>
             </a:r>
             <a:endParaRPr lang="en-US" sz="900" dirty="0"/>
           </a:p>
@@ -2774,7 +2774,7 @@
         </p:nvSpPr>
         <p:spPr>
           <a:xfrm>
-            <a:off x="6217920" y="4617720"/>
+            <a:off x="6217920" y="4663440"/>
             <a:ext cx="2606040" cy="320040"/>
           </a:xfrm>
           <a:prstGeom prst="rect">
@@ -2791,7 +2791,7 @@
               <a:buNone/>
             </a:pPr>
             <a:r>
-              <a:rPr lang="en-US" sz="1700" b="1" kern="0" dirty="0">
+              <a:rPr lang="en-US" sz="1500" b="1" kern="0" dirty="0">
                 <a:solidFill>
                   <a:srgbClr val="B08D57"/>
                 </a:solidFill>
@@ -2801,7 +2801,7 @@
               </a:rPr>
               <a:t>PRIVATE EQUITY</a:t>
             </a:r>
-            <a:endParaRPr lang="en-US" sz="1700" dirty="0"/>
+            <a:endParaRPr lang="en-US" sz="1500" dirty="0"/>
           </a:p>
         </p:txBody>
       </p:sp>
@@ -2814,7 +2814,7 @@
         <p:spPr>
           <a:xfrm>
             <a:off x="6217920" y="4983480"/>
-            <a:ext cx="2606040" cy="548640"/>
+            <a:ext cx="2606040" cy="731520"/>
           </a:xfrm>
           <a:prstGeom prst="rect">
             <a:avLst/>
@@ -2828,7 +2828,7 @@
           <a:p>
             <a:pPr marL="0" indent="0" algn="l">
               <a:lnSpc>
-                <a:spcPct val="112000"/>
+                <a:spcPct val="115000"/>
               </a:lnSpc>
               <a:buNone/>
             </a:pPr>
@@ -2841,7 +2841,7 @@
                 <a:ea typeface="Calibri" pitchFamily="34" charset="-122"/>
                 <a:cs typeface="Calibri" pitchFamily="34" charset="-120"/>
               </a:rPr>
-              <a:t>and private industry operating experience</a:t>
+              <a:t>PE-backed and private-industry operating experience: reporting packages, covenant tracking, and the lender-facing detail underwriting runs on.</a:t>
             </a:r>
             <a:endParaRPr lang="en-US" sz="900" dirty="0"/>
           </a:p>
@@ -2863,7 +2863,7 @@
         </p:blipFill>
         <p:spPr>
           <a:xfrm>
-            <a:off x="9806940" y="4572000"/>
+            <a:off x="9806940" y="4663440"/>
             <a:ext cx="1188720" cy="1188720"/>
           </a:xfrm>
           <a:prstGeom prst="rect">
@@ -2879,7 +2879,7 @@
         </p:nvSpPr>
         <p:spPr>
           <a:xfrm>
-            <a:off x="9189720" y="5788660"/>
+            <a:off x="9189720" y="5880100"/>
             <a:ext cx="2423160" cy="228600"/>
           </a:xfrm>
           <a:prstGeom prst="rect">
@@ -2918,8 +2918,8 @@
         </p:nvSpPr>
         <p:spPr>
           <a:xfrm>
-            <a:off x="548640" y="5943600"/>
-            <a:ext cx="8534400" cy="365760"/>
+            <a:off x="548640" y="6035040"/>
+            <a:ext cx="8534400" cy="320040"/>
           </a:xfrm>
           <a:prstGeom prst="rect">
             <a:avLst/>
@@ -2943,7 +2943,7 @@
                 <a:ea typeface="Calibri" pitchFamily="34" charset="-122"/>
                 <a:cs typeface="Calibri" pitchFamily="34" charset="-120"/>
               </a:rPr>
-              <a:t>Partner-level work, delivered by the people you actually talk to.</a:t>
+              <a:t>Every accountant on the team carries 10+ years. Partner-level work, delivered by the people you actually talk to.</a:t>
             </a:r>
             <a:endParaRPr lang="en-US" sz="1100" dirty="0"/>
           </a:p>

</xml_diff>